<commit_message>
Restructure reflection slide as from-to comparison
Co-Authored-By: Claude Opus 5.5 <noreply@anthropic.com>
Claude-Session: https://claude.ai/code/session_011iFrL2Hfizgp6kYckDtNGc
</commit_message>
<xml_diff>
--- a/思考页.pptx
+++ b/思考页.pptx
@@ -5689,8 +5689,8 @@
         </p:nvSpPr>
         <p:spPr>
           <a:xfrm>
-            <a:off x="457200" y="1508760"/>
-            <a:ext cx="5239512" cy="914400"/>
+            <a:off x="457200" y="1554480"/>
+            <a:ext cx="3383280" cy="3474720"/>
           </a:xfrm>
           <a:prstGeom prst="roundRect">
             <a:avLst>
@@ -5735,14 +5735,14 @@
         </p:nvSpPr>
         <p:spPr>
           <a:xfrm>
-            <a:off x="685800" y="1645920"/>
+            <a:off x="731520" y="1783080"/>
             <a:ext cx="640080" cy="640080"/>
           </a:xfrm>
           <a:prstGeom prst="ellipse">
             <a:avLst/>
           </a:prstGeom>
           <a:solidFill>
-            <a:srgbClr val="287DFA"/>
+            <a:srgbClr val="7A8599"/>
           </a:solidFill>
           <a:ln>
             <a:noFill/>
@@ -5785,7 +5785,7 @@
         </p:blipFill>
         <p:spPr>
           <a:xfrm>
-            <a:off x="845820" y="1805940"/>
+            <a:off x="891540" y="1943100"/>
             <a:ext cx="320040" cy="320040"/>
           </a:xfrm>
           <a:prstGeom prst="rect">
@@ -5801,8 +5801,8 @@
         </p:nvSpPr>
         <p:spPr>
           <a:xfrm>
-            <a:off x="1508760" y="1508760"/>
-            <a:ext cx="4069080" cy="914400"/>
+            <a:off x="1508760" y="1783080"/>
+            <a:ext cx="2194560" cy="640080"/>
           </a:xfrm>
           <a:prstGeom prst="rect">
             <a:avLst/>
@@ -5817,25 +5817,7 @@
           <a:p>
             <a:pPr algn="l"/>
             <a:r>
-              <a:rPr sz="1600" b="1">
-                <a:solidFill>
-                  <a:srgbClr val="15315E"/>
-                </a:solidFill>
-                <a:latin typeface="微软雅黑"/>
-                <a:ea typeface="微软雅黑"/>
-                <a:cs typeface="微软雅黑"/>
-              </a:rPr>
-              <a:t>火车票 Agent</a:t>
-            </a:r>
-          </a:p>
-          <a:p>
-            <a:pPr algn="l">
-              <a:spcBef>
-                <a:spcPts val="200"/>
-              </a:spcBef>
-            </a:pPr>
-            <a:r>
-              <a:rPr sz="1300" b="0">
+              <a:rPr sz="1800" b="1">
                 <a:solidFill>
                   <a:srgbClr val="3D4757"/>
                 </a:solidFill>
@@ -5843,34 +5825,196 @@
                 <a:ea typeface="微软雅黑"/>
                 <a:cs typeface="微软雅黑"/>
               </a:rPr>
-              <a:t>模型侧的质量工作，离业务结果比较远</a:t>
+              <a:t>AI native</a:t>
+            </a:r>
+          </a:p>
+          <a:p>
+            <a:pPr algn="l">
+              <a:spcBef>
+                <a:spcPts val="0"/>
+              </a:spcBef>
+            </a:pPr>
+            <a:r>
+              <a:rPr sz="1200" b="0">
+                <a:solidFill>
+                  <a:srgbClr val="7A8599"/>
+                </a:solidFill>
+                <a:latin typeface="微软雅黑"/>
+                <a:ea typeface="微软雅黑"/>
+                <a:cs typeface="微软雅黑"/>
+              </a:rPr>
+              <a:t>小红书</a:t>
             </a:r>
           </a:p>
         </p:txBody>
       </p:sp>
       <p:sp>
         <p:nvSpPr>
-          <p:cNvPr id="8" name="Rounded Rectangle 7"/>
+          <p:cNvPr id="8" name="TextBox 7"/>
+          <p:cNvSpPr txBox="1"/>
+          <p:nvPr/>
+        </p:nvSpPr>
+        <p:spPr>
+          <a:xfrm>
+            <a:off x="731520" y="2743200"/>
+            <a:ext cx="2834640" cy="274320"/>
+          </a:xfrm>
+          <a:prstGeom prst="rect">
+            <a:avLst/>
+          </a:prstGeom>
+          <a:noFill/>
+        </p:spPr>
+        <p:txBody>
+          <a:bodyPr wrap="square" lIns="0" rIns="0" tIns="0" bIns="0" anchor="t">
+            <a:spAutoFit/>
+          </a:bodyPr>
+          <a:lstStyle/>
+          <a:p>
+            <a:pPr algn="l"/>
+            <a:r>
+              <a:rPr sz="1200" b="1">
+                <a:solidFill>
+                  <a:srgbClr val="7A8599"/>
+                </a:solidFill>
+                <a:latin typeface="微软雅黑"/>
+                <a:ea typeface="微软雅黑"/>
+                <a:cs typeface="微软雅黑"/>
+              </a:rPr>
+              <a:t>定位</a:t>
+            </a:r>
+          </a:p>
+        </p:txBody>
+      </p:sp>
+      <p:sp>
+        <p:nvSpPr>
+          <p:cNvPr id="9" name="TextBox 8"/>
+          <p:cNvSpPr txBox="1"/>
+          <p:nvPr/>
+        </p:nvSpPr>
+        <p:spPr>
+          <a:xfrm>
+            <a:off x="731520" y="3035808"/>
+            <a:ext cx="2834640" cy="457200"/>
+          </a:xfrm>
+          <a:prstGeom prst="rect">
+            <a:avLst/>
+          </a:prstGeom>
+          <a:noFill/>
+        </p:spPr>
+        <p:txBody>
+          <a:bodyPr wrap="square" lIns="0" rIns="0" tIns="0" bIns="0" anchor="t">
+            <a:spAutoFit/>
+          </a:bodyPr>
+          <a:lstStyle/>
+          <a:p>
+            <a:pPr algn="l"/>
+            <a:r>
+              <a:rPr sz="1700" b="1">
+                <a:solidFill>
+                  <a:srgbClr val="3D4757"/>
+                </a:solidFill>
+                <a:latin typeface="微软雅黑"/>
+                <a:ea typeface="微软雅黑"/>
+                <a:cs typeface="微软雅黑"/>
+              </a:rPr>
+              <a:t>模型本身就是产品</a:t>
+            </a:r>
+          </a:p>
+        </p:txBody>
+      </p:sp>
+      <p:sp>
+        <p:nvSpPr>
+          <p:cNvPr id="10" name="TextBox 9"/>
+          <p:cNvSpPr txBox="1"/>
+          <p:nvPr/>
+        </p:nvSpPr>
+        <p:spPr>
+          <a:xfrm>
+            <a:off x="731520" y="3794760"/>
+            <a:ext cx="2834640" cy="274320"/>
+          </a:xfrm>
+          <a:prstGeom prst="rect">
+            <a:avLst/>
+          </a:prstGeom>
+          <a:noFill/>
+        </p:spPr>
+        <p:txBody>
+          <a:bodyPr wrap="square" lIns="0" rIns="0" tIns="0" bIns="0" anchor="t">
+            <a:spAutoFit/>
+          </a:bodyPr>
+          <a:lstStyle/>
+          <a:p>
+            <a:pPr algn="l"/>
+            <a:r>
+              <a:rPr sz="1200" b="1">
+                <a:solidFill>
+                  <a:srgbClr val="7A8599"/>
+                </a:solidFill>
+                <a:latin typeface="微软雅黑"/>
+                <a:ea typeface="微软雅黑"/>
+                <a:cs typeface="微软雅黑"/>
+              </a:rPr>
+              <a:t>衡量</a:t>
+            </a:r>
+          </a:p>
+        </p:txBody>
+      </p:sp>
+      <p:sp>
+        <p:nvSpPr>
+          <p:cNvPr id="11" name="TextBox 10"/>
+          <p:cNvSpPr txBox="1"/>
+          <p:nvPr/>
+        </p:nvSpPr>
+        <p:spPr>
+          <a:xfrm>
+            <a:off x="731520" y="4087368"/>
+            <a:ext cx="2834640" cy="457200"/>
+          </a:xfrm>
+          <a:prstGeom prst="rect">
+            <a:avLst/>
+          </a:prstGeom>
+          <a:noFill/>
+        </p:spPr>
+        <p:txBody>
+          <a:bodyPr wrap="square" lIns="0" rIns="0" tIns="0" bIns="0" anchor="t">
+            <a:spAutoFit/>
+          </a:bodyPr>
+          <a:lstStyle/>
+          <a:p>
+            <a:pPr algn="l"/>
+            <a:r>
+              <a:rPr sz="1700" b="1">
+                <a:solidFill>
+                  <a:srgbClr val="3D4757"/>
+                </a:solidFill>
+                <a:latin typeface="微软雅黑"/>
+                <a:ea typeface="微软雅黑"/>
+                <a:cs typeface="微软雅黑"/>
+              </a:rPr>
+              <a:t>模型表现得好不好</a:t>
+            </a:r>
+          </a:p>
+        </p:txBody>
+      </p:sp>
+      <p:sp>
+        <p:nvSpPr>
+          <p:cNvPr id="12" name="arrow"/>
           <p:cNvSpPr/>
           <p:nvPr/>
         </p:nvSpPr>
         <p:spPr>
           <a:xfrm>
-            <a:off x="6492240" y="1508760"/>
-            <a:ext cx="5239512" cy="914400"/>
-          </a:xfrm>
-          <a:prstGeom prst="roundRect">
-            <a:avLst>
-              <a:gd name="adj" fmla="val 6000"/>
-            </a:avLst>
+            <a:off x="3977639" y="3063240"/>
+            <a:ext cx="502920" cy="457200"/>
+          </a:xfrm>
+          <a:prstGeom prst="rightArrow">
+            <a:avLst/>
           </a:prstGeom>
           <a:solidFill>
-            <a:srgbClr val="F5F9FF"/>
+            <a:srgbClr val="287DFA"/>
           </a:solidFill>
-          <a:ln w="12700">
-            <a:solidFill>
-              <a:srgbClr val="D3E2FB"/>
-            </a:solidFill>
+          <a:ln>
+            <a:noFill/>
           </a:ln>
           <a:effectLst/>
         </p:spPr>
@@ -5896,13 +6040,59 @@
       </p:sp>
       <p:sp>
         <p:nvSpPr>
-          <p:cNvPr id="9" name="icon-circle"/>
+          <p:cNvPr id="13" name="Rounded Rectangle 12"/>
           <p:cNvSpPr/>
           <p:nvPr/>
         </p:nvSpPr>
         <p:spPr>
           <a:xfrm>
-            <a:off x="6720840" y="1645920"/>
+            <a:off x="4617720" y="1554480"/>
+            <a:ext cx="7114032" cy="3474720"/>
+          </a:xfrm>
+          <a:prstGeom prst="roundRect">
+            <a:avLst>
+              <a:gd name="adj" fmla="val 6000"/>
+            </a:avLst>
+          </a:prstGeom>
+          <a:solidFill>
+            <a:srgbClr val="EAF2FF"/>
+          </a:solidFill>
+          <a:ln w="12700">
+            <a:solidFill>
+              <a:srgbClr val="287DFA"/>
+            </a:solidFill>
+          </a:ln>
+          <a:effectLst/>
+        </p:spPr>
+        <p:style>
+          <a:lnRef idx="1">
+            <a:schemeClr val="accent1"/>
+          </a:lnRef>
+          <a:fillRef idx="3">
+            <a:schemeClr val="accent1"/>
+          </a:fillRef>
+          <a:effectRef idx="2">
+            <a:schemeClr val="accent1"/>
+          </a:effectRef>
+          <a:fontRef idx="minor">
+            <a:schemeClr val="lt1"/>
+          </a:fontRef>
+        </p:style>
+        <p:txBody>
+          <a:bodyPr rtlCol="0" anchor="ctr"/>
+          <a:lstStyle/>
+          <a:p/>
+        </p:txBody>
+      </p:sp>
+      <p:sp>
+        <p:nvSpPr>
+          <p:cNvPr id="14" name="icon-circle"/>
+          <p:cNvSpPr/>
+          <p:nvPr/>
+        </p:nvSpPr>
+        <p:spPr>
+          <a:xfrm>
+            <a:off x="4892040" y="1783080"/>
             <a:ext cx="640080" cy="640080"/>
           </a:xfrm>
           <a:prstGeom prst="ellipse">
@@ -5938,7 +6128,7 @@
       </p:sp>
       <p:pic>
         <p:nvPicPr>
-          <p:cNvPr id="10" name="Picture 9" descr="FaTicket_w.png"/>
+          <p:cNvPr id="15" name="Picture 14" descr="FaTicket_w.png"/>
           <p:cNvPicPr>
             <a:picLocks noChangeAspect="1"/>
           </p:cNvPicPr>
@@ -5952,7 +6142,7 @@
         </p:blipFill>
         <p:spPr>
           <a:xfrm>
-            <a:off x="6880859" y="1805940"/>
+            <a:off x="5052059" y="1943100"/>
             <a:ext cx="320040" cy="320040"/>
           </a:xfrm>
           <a:prstGeom prst="rect">
@@ -5962,14 +6152,14 @@
       </p:pic>
       <p:sp>
         <p:nvSpPr>
-          <p:cNvPr id="11" name="TextBox 10"/>
+          <p:cNvPr id="16" name="TextBox 15"/>
           <p:cNvSpPr txBox="1"/>
           <p:nvPr/>
         </p:nvSpPr>
         <p:spPr>
           <a:xfrm>
-            <a:off x="7543800" y="1508760"/>
-            <a:ext cx="4069080" cy="914400"/>
+            <a:off x="5669280" y="1783080"/>
+            <a:ext cx="2743200" cy="640080"/>
           </a:xfrm>
           <a:prstGeom prst="rect">
             <a:avLst/>
@@ -5984,7 +6174,62 @@
           <a:p>
             <a:pPr algn="l"/>
             <a:r>
-              <a:rPr sz="1600" b="1">
+              <a:rPr sz="1800" b="1">
+                <a:solidFill>
+                  <a:srgbClr val="287DFA"/>
+                </a:solidFill>
+                <a:latin typeface="微软雅黑"/>
+                <a:ea typeface="微软雅黑"/>
+                <a:cs typeface="微软雅黑"/>
+              </a:rPr>
+              <a:t>AI × 业务</a:t>
+            </a:r>
+          </a:p>
+          <a:p>
+            <a:pPr algn="l">
+              <a:spcBef>
+                <a:spcPts val="0"/>
+              </a:spcBef>
+            </a:pPr>
+            <a:r>
+              <a:rPr sz="1200" b="0">
+                <a:solidFill>
+                  <a:srgbClr val="7A8599"/>
+                </a:solidFill>
+                <a:latin typeface="微软雅黑"/>
+                <a:ea typeface="微软雅黑"/>
+                <a:cs typeface="微软雅黑"/>
+              </a:rPr>
+              <a:t>携程 · 火车票</a:t>
+            </a:r>
+          </a:p>
+        </p:txBody>
+      </p:sp>
+      <p:sp>
+        <p:nvSpPr>
+          <p:cNvPr id="17" name="TextBox 16"/>
+          <p:cNvSpPr txBox="1"/>
+          <p:nvPr/>
+        </p:nvSpPr>
+        <p:spPr>
+          <a:xfrm>
+            <a:off x="8229600" y="1783080"/>
+            <a:ext cx="3291840" cy="640080"/>
+          </a:xfrm>
+          <a:prstGeom prst="rect">
+            <a:avLst/>
+          </a:prstGeom>
+          <a:noFill/>
+        </p:spPr>
+        <p:txBody>
+          <a:bodyPr wrap="square" lIns="0" rIns="0" tIns="0" bIns="0" anchor="ctr">
+            <a:spAutoFit/>
+          </a:bodyPr>
+          <a:lstStyle/>
+          <a:p>
+            <a:pPr algn="r"/>
+            <a:r>
+              <a:rPr sz="1500" b="1">
                 <a:solidFill>
                   <a:srgbClr val="15315E"/>
                 </a:solidFill>
@@ -5992,45 +6237,29 @@
                 <a:ea typeface="微软雅黑"/>
                 <a:cs typeface="微软雅黑"/>
               </a:rPr>
-              <a:t>抢票业务</a:t>
-            </a:r>
-          </a:p>
-          <a:p>
-            <a:pPr algn="l">
-              <a:spcBef>
-                <a:spcPts val="200"/>
-              </a:spcBef>
-            </a:pPr>
-            <a:r>
-              <a:rPr sz="1300" b="0">
-                <a:solidFill>
-                  <a:srgbClr val="3D4757"/>
-                </a:solidFill>
-                <a:latin typeface="微软雅黑"/>
-                <a:ea typeface="微软雅黑"/>
-                <a:cs typeface="微软雅黑"/>
-              </a:rPr>
-              <a:t>直接对票量负责，学会从业务指标倒推要做什么</a:t>
+              <a:t>定位：AI 是服务业务的手段</a:t>
             </a:r>
           </a:p>
         </p:txBody>
       </p:sp>
       <p:sp>
         <p:nvSpPr>
-          <p:cNvPr id="12" name="arrow"/>
+          <p:cNvPr id="18" name="Rounded Rectangle 17"/>
           <p:cNvSpPr/>
           <p:nvPr/>
         </p:nvSpPr>
         <p:spPr>
           <a:xfrm>
-            <a:off x="5806440" y="1801368"/>
-            <a:ext cx="457200" cy="329184"/>
-          </a:xfrm>
-          <a:prstGeom prst="rightArrow">
-            <a:avLst/>
+            <a:off x="4892040" y="2697480"/>
+            <a:ext cx="6583680" cy="621792"/>
+          </a:xfrm>
+          <a:prstGeom prst="roundRect">
+            <a:avLst>
+              <a:gd name="adj" fmla="val 15000"/>
+            </a:avLst>
           </a:prstGeom>
           <a:solidFill>
-            <a:srgbClr val="287DFA"/>
+            <a:srgbClr val="FFFFFF"/>
           </a:solidFill>
           <a:ln>
             <a:noFill/>
@@ -6059,14 +6288,80 @@
       </p:sp>
       <p:sp>
         <p:nvSpPr>
-          <p:cNvPr id="13" name="TextBox 12"/>
+          <p:cNvPr id="19" name="icon-circle"/>
+          <p:cNvSpPr/>
+          <p:nvPr/>
+        </p:nvSpPr>
+        <p:spPr>
+          <a:xfrm>
+            <a:off x="5029200" y="2798064"/>
+            <a:ext cx="420624" cy="420624"/>
+          </a:xfrm>
+          <a:prstGeom prst="ellipse">
+            <a:avLst/>
+          </a:prstGeom>
+          <a:solidFill>
+            <a:srgbClr val="287DFA"/>
+          </a:solidFill>
+          <a:ln>
+            <a:noFill/>
+          </a:ln>
+          <a:effectLst/>
+        </p:spPr>
+        <p:style>
+          <a:lnRef idx="1">
+            <a:schemeClr val="accent1"/>
+          </a:lnRef>
+          <a:fillRef idx="3">
+            <a:schemeClr val="accent1"/>
+          </a:fillRef>
+          <a:effectRef idx="2">
+            <a:schemeClr val="accent1"/>
+          </a:effectRef>
+          <a:fontRef idx="minor">
+            <a:schemeClr val="lt1"/>
+          </a:fontRef>
+        </p:style>
+        <p:txBody>
+          <a:bodyPr rtlCol="0" anchor="ctr"/>
+          <a:lstStyle/>
+          <a:p/>
+        </p:txBody>
+      </p:sp>
+      <p:pic>
+        <p:nvPicPr>
+          <p:cNvPr id="20" name="Picture 19" descr="FaLayerGroup_w.png"/>
+          <p:cNvPicPr>
+            <a:picLocks noChangeAspect="1"/>
+          </p:cNvPicPr>
+          <p:nvPr/>
+        </p:nvPicPr>
+        <p:blipFill>
+          <a:blip r:embed="rId5"/>
+          <a:stretch>
+            <a:fillRect/>
+          </a:stretch>
+        </p:blipFill>
+        <p:spPr>
+          <a:xfrm>
+            <a:off x="5134356" y="2903220"/>
+            <a:ext cx="210312" cy="210312"/>
+          </a:xfrm>
+          <a:prstGeom prst="rect">
+            <a:avLst/>
+          </a:prstGeom>
+        </p:spPr>
+      </p:pic>
+      <p:sp>
+        <p:nvSpPr>
+          <p:cNvPr id="21" name="TextBox 20"/>
           <p:cNvSpPr txBox="1"/>
           <p:nvPr/>
         </p:nvSpPr>
         <p:spPr>
           <a:xfrm>
-            <a:off x="457200" y="2697480"/>
-            <a:ext cx="11274552" cy="320040"/>
+            <a:off x="5577840" y="2697480"/>
+            <a:ext cx="731520" cy="621792"/>
           </a:xfrm>
           <a:prstGeom prst="rect">
             <a:avLst/>
@@ -6074,36 +6369,14 @@
           <a:noFill/>
         </p:spPr>
         <p:txBody>
-          <a:bodyPr wrap="square" lIns="0" rIns="0" tIns="0" bIns="0" anchor="t">
+          <a:bodyPr wrap="square" lIns="0" rIns="0" tIns="0" bIns="0" anchor="ctr">
             <a:spAutoFit/>
           </a:bodyPr>
           <a:lstStyle/>
           <a:p>
             <a:pPr algn="l"/>
             <a:r>
-              <a:rPr sz="1300" b="1">
-                <a:solidFill>
-                  <a:srgbClr val="7A8599"/>
-                </a:solidFill>
-                <a:latin typeface="微软雅黑"/>
-                <a:ea typeface="微软雅黑"/>
-                <a:cs typeface="微软雅黑"/>
-              </a:rPr>
-              <a:t>AI native：</a:t>
-            </a:r>
-            <a:r>
-              <a:rPr sz="1300" b="0">
-                <a:solidFill>
-                  <a:srgbClr val="7A8599"/>
-                </a:solidFill>
-                <a:latin typeface="微软雅黑"/>
-                <a:ea typeface="微软雅黑"/>
-                <a:cs typeface="微软雅黑"/>
-              </a:rPr>
-              <a:t>模型本身就是产品，衡量的是模型表现　　</a:t>
-            </a:r>
-            <a:r>
-              <a:rPr sz="1300" b="1">
+              <a:rPr sz="1500" b="1">
                 <a:solidFill>
                   <a:srgbClr val="287DFA"/>
                 </a:solidFill>
@@ -6111,45 +6384,69 @@
                 <a:ea typeface="微软雅黑"/>
                 <a:cs typeface="微软雅黑"/>
               </a:rPr>
-              <a:t>AI × 业务：</a:t>
-            </a:r>
-            <a:r>
-              <a:rPr sz="1300" b="0">
-                <a:solidFill>
-                  <a:srgbClr val="287DFA"/>
-                </a:solidFill>
-                <a:latin typeface="微软雅黑"/>
-                <a:ea typeface="微软雅黑"/>
-                <a:cs typeface="微软雅黑"/>
-              </a:rPr>
-              <a:t>AI 是服务业务的手段</a:t>
+              <a:t>边界</a:t>
             </a:r>
           </a:p>
         </p:txBody>
       </p:sp>
       <p:sp>
         <p:nvSpPr>
-          <p:cNvPr id="14" name="Rounded Rectangle 13"/>
+          <p:cNvPr id="22" name="TextBox 21"/>
+          <p:cNvSpPr txBox="1"/>
+          <p:nvPr/>
+        </p:nvSpPr>
+        <p:spPr>
+          <a:xfrm>
+            <a:off x="6309360" y="2697480"/>
+            <a:ext cx="5074920" cy="621792"/>
+          </a:xfrm>
+          <a:prstGeom prst="rect">
+            <a:avLst/>
+          </a:prstGeom>
+          <a:noFill/>
+        </p:spPr>
+        <p:txBody>
+          <a:bodyPr wrap="square" lIns="0" rIns="0" tIns="0" bIns="0" anchor="ctr">
+            <a:spAutoFit/>
+          </a:bodyPr>
+          <a:lstStyle/>
+          <a:p>
+            <a:pPr algn="l"/>
+            <a:r>
+              <a:rPr sz="1400" b="0">
+                <a:solidFill>
+                  <a:srgbClr val="3D4757"/>
+                </a:solidFill>
+                <a:latin typeface="微软雅黑"/>
+                <a:ea typeface="微软雅黑"/>
+                <a:cs typeface="微软雅黑"/>
+              </a:rPr>
+              <a:t>由业务来定：什么属于火车、什么不属于</a:t>
+            </a:r>
+          </a:p>
+        </p:txBody>
+      </p:sp>
+      <p:sp>
+        <p:nvSpPr>
+          <p:cNvPr id="23" name="Rounded Rectangle 22"/>
           <p:cNvSpPr/>
           <p:nvPr/>
         </p:nvSpPr>
         <p:spPr>
           <a:xfrm>
-            <a:off x="457200" y="3200400"/>
-            <a:ext cx="3630168" cy="1828800"/>
+            <a:off x="4892040" y="3447288"/>
+            <a:ext cx="6583680" cy="621792"/>
           </a:xfrm>
           <a:prstGeom prst="roundRect">
             <a:avLst>
-              <a:gd name="adj" fmla="val 6000"/>
+              <a:gd name="adj" fmla="val 15000"/>
             </a:avLst>
           </a:prstGeom>
           <a:solidFill>
             <a:srgbClr val="FFFFFF"/>
           </a:solidFill>
-          <a:ln w="12700">
-            <a:solidFill>
-              <a:srgbClr val="D3E2FB"/>
-            </a:solidFill>
+          <a:ln>
+            <a:noFill/>
           </a:ln>
           <a:effectLst/>
         </p:spPr>
@@ -6175,14 +6472,14 @@
       </p:sp>
       <p:sp>
         <p:nvSpPr>
-          <p:cNvPr id="15" name="icon-circle"/>
+          <p:cNvPr id="24" name="icon-circle"/>
           <p:cNvSpPr/>
           <p:nvPr/>
         </p:nvSpPr>
         <p:spPr>
           <a:xfrm>
-            <a:off x="731520" y="3429000"/>
-            <a:ext cx="685800" cy="685800"/>
+            <a:off x="5029200" y="3547872"/>
+            <a:ext cx="420624" cy="420624"/>
           </a:xfrm>
           <a:prstGeom prst="ellipse">
             <a:avLst/>
@@ -6217,22 +6514,22 @@
       </p:sp>
       <p:pic>
         <p:nvPicPr>
-          <p:cNvPr id="16" name="Picture 15" descr="FaLayerGroup_w.png"/>
+          <p:cNvPr id="25" name="Picture 24" descr="FaHandshake_w.png"/>
           <p:cNvPicPr>
             <a:picLocks noChangeAspect="1"/>
           </p:cNvPicPr>
           <p:nvPr/>
         </p:nvPicPr>
         <p:blipFill>
-          <a:blip r:embed="rId5"/>
+          <a:blip r:embed="rId6"/>
           <a:stretch>
             <a:fillRect/>
           </a:stretch>
         </p:blipFill>
         <p:spPr>
           <a:xfrm>
-            <a:off x="902970" y="3600450"/>
-            <a:ext cx="342900" cy="342900"/>
+            <a:off x="5134356" y="3653028"/>
+            <a:ext cx="210312" cy="210312"/>
           </a:xfrm>
           <a:prstGeom prst="rect">
             <a:avLst/>
@@ -6241,14 +6538,14 @@
       </p:pic>
       <p:sp>
         <p:nvSpPr>
-          <p:cNvPr id="17" name="TextBox 16"/>
+          <p:cNvPr id="26" name="TextBox 25"/>
           <p:cNvSpPr txBox="1"/>
           <p:nvPr/>
         </p:nvSpPr>
         <p:spPr>
           <a:xfrm>
-            <a:off x="1600200" y="3429000"/>
-            <a:ext cx="2377440" cy="685800"/>
+            <a:off x="5577840" y="3447288"/>
+            <a:ext cx="731520" cy="621792"/>
           </a:xfrm>
           <a:prstGeom prst="rect">
             <a:avLst/>
@@ -6263,29 +6560,29 @@
           <a:p>
             <a:pPr algn="l"/>
             <a:r>
-              <a:rPr sz="1700" b="1">
+              <a:rPr sz="1500" b="1">
                 <a:solidFill>
-                  <a:srgbClr val="15315E"/>
+                  <a:srgbClr val="287DFA"/>
                 </a:solidFill>
                 <a:latin typeface="微软雅黑"/>
                 <a:ea typeface="微软雅黑"/>
                 <a:cs typeface="微软雅黑"/>
               </a:rPr>
-              <a:t>边界由业务来定</a:t>
+              <a:t>形态</a:t>
             </a:r>
           </a:p>
         </p:txBody>
       </p:sp>
       <p:sp>
         <p:nvSpPr>
-          <p:cNvPr id="18" name="TextBox 17"/>
+          <p:cNvPr id="27" name="TextBox 26"/>
           <p:cNvSpPr txBox="1"/>
           <p:nvPr/>
         </p:nvSpPr>
         <p:spPr>
           <a:xfrm>
-            <a:off x="731520" y="4297680"/>
-            <a:ext cx="3108960" cy="640080"/>
+            <a:off x="6309360" y="3447288"/>
+            <a:ext cx="5074920" cy="621792"/>
           </a:xfrm>
           <a:prstGeom prst="rect">
             <a:avLst/>
@@ -6293,14 +6590,14 @@
           <a:noFill/>
         </p:spPr>
         <p:txBody>
-          <a:bodyPr wrap="square" lIns="0" rIns="0" tIns="0" bIns="0" anchor="t">
+          <a:bodyPr wrap="square" lIns="0" rIns="0" tIns="0" bIns="0" anchor="ctr">
             <a:spAutoFit/>
           </a:bodyPr>
           <a:lstStyle/>
           <a:p>
             <a:pPr algn="l"/>
             <a:r>
-              <a:rPr sz="1300" b="0">
+              <a:rPr sz="1400" b="0">
                 <a:solidFill>
                   <a:srgbClr val="3D4757"/>
                 </a:solidFill>
@@ -6308,34 +6605,32 @@
                 <a:ea typeface="微软雅黑"/>
                 <a:cs typeface="微软雅黑"/>
               </a:rPr>
-              <a:t>什么属于火车、什么不属于</a:t>
+              <a:t>贴合用户习惯：对话 → 直接操作列表页，票量明显提升</a:t>
             </a:r>
           </a:p>
         </p:txBody>
       </p:sp>
       <p:sp>
         <p:nvSpPr>
-          <p:cNvPr id="19" name="Rounded Rectangle 18"/>
+          <p:cNvPr id="28" name="Rounded Rectangle 27"/>
           <p:cNvSpPr/>
           <p:nvPr/>
         </p:nvSpPr>
         <p:spPr>
           <a:xfrm>
-            <a:off x="4279392" y="3200400"/>
-            <a:ext cx="3630168" cy="1828800"/>
+            <a:off x="4892040" y="4197096"/>
+            <a:ext cx="6583680" cy="621792"/>
           </a:xfrm>
           <a:prstGeom prst="roundRect">
             <a:avLst>
-              <a:gd name="adj" fmla="val 6000"/>
+              <a:gd name="adj" fmla="val 15000"/>
             </a:avLst>
           </a:prstGeom>
           <a:solidFill>
             <a:srgbClr val="FFFFFF"/>
           </a:solidFill>
-          <a:ln w="12700">
-            <a:solidFill>
-              <a:srgbClr val="D3E2FB"/>
-            </a:solidFill>
+          <a:ln>
+            <a:noFill/>
           </a:ln>
           <a:effectLst/>
         </p:spPr>
@@ -6361,14 +6656,14 @@
       </p:sp>
       <p:sp>
         <p:nvSpPr>
-          <p:cNvPr id="20" name="icon-circle"/>
+          <p:cNvPr id="29" name="icon-circle"/>
           <p:cNvSpPr/>
           <p:nvPr/>
         </p:nvSpPr>
         <p:spPr>
           <a:xfrm>
-            <a:off x="4553712" y="3429000"/>
-            <a:ext cx="685800" cy="685800"/>
+            <a:off x="5029200" y="4297680"/>
+            <a:ext cx="420624" cy="420624"/>
           </a:xfrm>
           <a:prstGeom prst="ellipse">
             <a:avLst/>
@@ -6403,22 +6698,22 @@
       </p:sp>
       <p:pic>
         <p:nvPicPr>
-          <p:cNvPr id="21" name="Picture 20" descr="FaHandshake_w.png"/>
+          <p:cNvPr id="30" name="Picture 29" descr="FaChartLine_w.png"/>
           <p:cNvPicPr>
             <a:picLocks noChangeAspect="1"/>
           </p:cNvPicPr>
           <p:nvPr/>
         </p:nvPicPr>
         <p:blipFill>
-          <a:blip r:embed="rId6"/>
+          <a:blip r:embed="rId7"/>
           <a:stretch>
             <a:fillRect/>
           </a:stretch>
         </p:blipFill>
         <p:spPr>
           <a:xfrm>
-            <a:off x="4725162" y="3600450"/>
-            <a:ext cx="342900" cy="342900"/>
+            <a:off x="5134356" y="4402836"/>
+            <a:ext cx="210312" cy="210312"/>
           </a:xfrm>
           <a:prstGeom prst="rect">
             <a:avLst/>
@@ -6427,14 +6722,14 @@
       </p:pic>
       <p:sp>
         <p:nvSpPr>
-          <p:cNvPr id="22" name="TextBox 21"/>
+          <p:cNvPr id="31" name="TextBox 30"/>
           <p:cNvSpPr txBox="1"/>
           <p:nvPr/>
         </p:nvSpPr>
         <p:spPr>
           <a:xfrm>
-            <a:off x="5422392" y="3429000"/>
-            <a:ext cx="2377440" cy="685800"/>
+            <a:off x="5577840" y="4197096"/>
+            <a:ext cx="731520" cy="621792"/>
           </a:xfrm>
           <a:prstGeom prst="rect">
             <a:avLst/>
@@ -6449,29 +6744,29 @@
           <a:p>
             <a:pPr algn="l"/>
             <a:r>
-              <a:rPr sz="1700" b="1">
+              <a:rPr sz="1500" b="1">
                 <a:solidFill>
-                  <a:srgbClr val="15315E"/>
+                  <a:srgbClr val="287DFA"/>
                 </a:solidFill>
                 <a:latin typeface="微软雅黑"/>
                 <a:ea typeface="微软雅黑"/>
                 <a:cs typeface="微软雅黑"/>
               </a:rPr>
-              <a:t>形态贴合用户习惯</a:t>
+              <a:t>衡量</a:t>
             </a:r>
           </a:p>
         </p:txBody>
       </p:sp>
       <p:sp>
         <p:nvSpPr>
-          <p:cNvPr id="23" name="TextBox 22"/>
+          <p:cNvPr id="32" name="TextBox 31"/>
           <p:cNvSpPr txBox="1"/>
           <p:nvPr/>
         </p:nvSpPr>
         <p:spPr>
           <a:xfrm>
-            <a:off x="4553712" y="4297680"/>
-            <a:ext cx="3108960" cy="640080"/>
+            <a:off x="6309360" y="4197096"/>
+            <a:ext cx="5074920" cy="621792"/>
           </a:xfrm>
           <a:prstGeom prst="rect">
             <a:avLst/>
@@ -6479,14 +6774,14 @@
           <a:noFill/>
         </p:spPr>
         <p:txBody>
-          <a:bodyPr wrap="square" lIns="0" rIns="0" tIns="0" bIns="0" anchor="t">
+          <a:bodyPr wrap="square" lIns="0" rIns="0" tIns="0" bIns="0" anchor="ctr">
             <a:spAutoFit/>
           </a:bodyPr>
           <a:lstStyle/>
           <a:p>
             <a:pPr algn="l"/>
             <a:r>
-              <a:rPr sz="1300" b="0">
+              <a:rPr sz="1400" b="0">
                 <a:solidFill>
                   <a:srgbClr val="3D4757"/>
                 </a:solidFill>
@@ -6494,70 +6789,26 @@
                 <a:ea typeface="微软雅黑"/>
                 <a:cs typeface="微软雅黑"/>
               </a:rPr>
-              <a:t>二期把对话改成直接操作列表页，票量明显提升</a:t>
+              <a:t>票量这样的业务结果</a:t>
             </a:r>
           </a:p>
         </p:txBody>
       </p:sp>
       <p:sp>
         <p:nvSpPr>
-          <p:cNvPr id="24" name="Rounded Rectangle 23"/>
+          <p:cNvPr id="33" name="Rounded Rectangle 32"/>
           <p:cNvSpPr/>
           <p:nvPr/>
         </p:nvSpPr>
         <p:spPr>
           <a:xfrm>
-            <a:off x="8101583" y="3200400"/>
-            <a:ext cx="3630168" cy="1828800"/>
+            <a:off x="457200" y="5257800"/>
+            <a:ext cx="11274552" cy="822960"/>
           </a:xfrm>
           <a:prstGeom prst="roundRect">
             <a:avLst>
               <a:gd name="adj" fmla="val 6000"/>
             </a:avLst>
-          </a:prstGeom>
-          <a:solidFill>
-            <a:srgbClr val="FFFFFF"/>
-          </a:solidFill>
-          <a:ln w="12700">
-            <a:solidFill>
-              <a:srgbClr val="D3E2FB"/>
-            </a:solidFill>
-          </a:ln>
-          <a:effectLst/>
-        </p:spPr>
-        <p:style>
-          <a:lnRef idx="1">
-            <a:schemeClr val="accent1"/>
-          </a:lnRef>
-          <a:fillRef idx="3">
-            <a:schemeClr val="accent1"/>
-          </a:fillRef>
-          <a:effectRef idx="2">
-            <a:schemeClr val="accent1"/>
-          </a:effectRef>
-          <a:fontRef idx="minor">
-            <a:schemeClr val="lt1"/>
-          </a:fontRef>
-        </p:style>
-        <p:txBody>
-          <a:bodyPr rtlCol="0" anchor="ctr"/>
-          <a:lstStyle/>
-          <a:p/>
-        </p:txBody>
-      </p:sp>
-      <p:sp>
-        <p:nvSpPr>
-          <p:cNvPr id="25" name="icon-circle"/>
-          <p:cNvSpPr/>
-          <p:nvPr/>
-        </p:nvSpPr>
-        <p:spPr>
-          <a:xfrm>
-            <a:off x="8375904" y="3429000"/>
-            <a:ext cx="685800" cy="685800"/>
-          </a:xfrm>
-          <a:prstGeom prst="ellipse">
-            <a:avLst/>
           </a:prstGeom>
           <a:solidFill>
             <a:srgbClr val="287DFA"/>
@@ -6589,149 +6840,7 @@
       </p:sp>
       <p:pic>
         <p:nvPicPr>
-          <p:cNvPr id="26" name="Picture 25" descr="FaChartLine_w.png"/>
-          <p:cNvPicPr>
-            <a:picLocks noChangeAspect="1"/>
-          </p:cNvPicPr>
-          <p:nvPr/>
-        </p:nvPicPr>
-        <p:blipFill>
-          <a:blip r:embed="rId7"/>
-          <a:stretch>
-            <a:fillRect/>
-          </a:stretch>
-        </p:blipFill>
-        <p:spPr>
-          <a:xfrm>
-            <a:off x="8547354" y="3600450"/>
-            <a:ext cx="342900" cy="342900"/>
-          </a:xfrm>
-          <a:prstGeom prst="rect">
-            <a:avLst/>
-          </a:prstGeom>
-        </p:spPr>
-      </p:pic>
-      <p:sp>
-        <p:nvSpPr>
-          <p:cNvPr id="27" name="TextBox 26"/>
-          <p:cNvSpPr txBox="1"/>
-          <p:nvPr/>
-        </p:nvSpPr>
-        <p:spPr>
-          <a:xfrm>
-            <a:off x="9244584" y="3429000"/>
-            <a:ext cx="2377440" cy="685800"/>
-          </a:xfrm>
-          <a:prstGeom prst="rect">
-            <a:avLst/>
-          </a:prstGeom>
-          <a:noFill/>
-        </p:spPr>
-        <p:txBody>
-          <a:bodyPr wrap="square" lIns="0" rIns="0" tIns="0" bIns="0" anchor="ctr">
-            <a:spAutoFit/>
-          </a:bodyPr>
-          <a:lstStyle/>
-          <a:p>
-            <a:pPr algn="l"/>
-            <a:r>
-              <a:rPr sz="1700" b="1">
-                <a:solidFill>
-                  <a:srgbClr val="15315E"/>
-                </a:solidFill>
-                <a:latin typeface="微软雅黑"/>
-                <a:ea typeface="微软雅黑"/>
-                <a:cs typeface="微软雅黑"/>
-              </a:rPr>
-              <a:t>用业务结果衡量</a:t>
-            </a:r>
-          </a:p>
-        </p:txBody>
-      </p:sp>
-      <p:sp>
-        <p:nvSpPr>
-          <p:cNvPr id="28" name="TextBox 27"/>
-          <p:cNvSpPr txBox="1"/>
-          <p:nvPr/>
-        </p:nvSpPr>
-        <p:spPr>
-          <a:xfrm>
-            <a:off x="8375904" y="4297680"/>
-            <a:ext cx="3108960" cy="640080"/>
-          </a:xfrm>
-          <a:prstGeom prst="rect">
-            <a:avLst/>
-          </a:prstGeom>
-          <a:noFill/>
-        </p:spPr>
-        <p:txBody>
-          <a:bodyPr wrap="square" lIns="0" rIns="0" tIns="0" bIns="0" anchor="t">
-            <a:spAutoFit/>
-          </a:bodyPr>
-          <a:lstStyle/>
-          <a:p>
-            <a:pPr algn="l"/>
-            <a:r>
-              <a:rPr sz="1300" b="0">
-                <a:solidFill>
-                  <a:srgbClr val="3D4757"/>
-                </a:solidFill>
-                <a:latin typeface="微软雅黑"/>
-                <a:ea typeface="微软雅黑"/>
-                <a:cs typeface="微软雅黑"/>
-              </a:rPr>
-              <a:t>最终看的是票量这样的业务结果</a:t>
-            </a:r>
-          </a:p>
-        </p:txBody>
-      </p:sp>
-      <p:sp>
-        <p:nvSpPr>
-          <p:cNvPr id="29" name="Rounded Rectangle 28"/>
-          <p:cNvSpPr/>
-          <p:nvPr/>
-        </p:nvSpPr>
-        <p:spPr>
-          <a:xfrm>
-            <a:off x="457200" y="5257800"/>
-            <a:ext cx="11274552" cy="822960"/>
-          </a:xfrm>
-          <a:prstGeom prst="roundRect">
-            <a:avLst>
-              <a:gd name="adj" fmla="val 6000"/>
-            </a:avLst>
-          </a:prstGeom>
-          <a:solidFill>
-            <a:srgbClr val="287DFA"/>
-          </a:solidFill>
-          <a:ln>
-            <a:noFill/>
-          </a:ln>
-          <a:effectLst/>
-        </p:spPr>
-        <p:style>
-          <a:lnRef idx="1">
-            <a:schemeClr val="accent1"/>
-          </a:lnRef>
-          <a:fillRef idx="3">
-            <a:schemeClr val="accent1"/>
-          </a:fillRef>
-          <a:effectRef idx="2">
-            <a:schemeClr val="accent1"/>
-          </a:effectRef>
-          <a:fontRef idx="minor">
-            <a:schemeClr val="lt1"/>
-          </a:fontRef>
-        </p:style>
-        <p:txBody>
-          <a:bodyPr rtlCol="0" anchor="ctr"/>
-          <a:lstStyle/>
-          <a:p/>
-        </p:txBody>
-      </p:sp>
-      <p:pic>
-        <p:nvPicPr>
-          <p:cNvPr id="30" name="Picture 29" descr="FaLightbulb_w.png"/>
+          <p:cNvPr id="34" name="Picture 33" descr="FaLightbulb_w.png"/>
           <p:cNvPicPr>
             <a:picLocks noChangeAspect="1"/>
           </p:cNvPicPr>
@@ -6755,7 +6864,7 @@
       </p:pic>
       <p:sp>
         <p:nvSpPr>
-          <p:cNvPr id="31" name="TextBox 30"/>
+          <p:cNvPr id="35" name="TextBox 34"/>
           <p:cNvSpPr txBox="1"/>
           <p:nvPr/>
         </p:nvSpPr>

</xml_diff>

<commit_message>
Relabel reflection slide by responsibility instead of company
Co-Authored-By: Claude Opus 5.5 <noreply@anthropic.com>
Claude-Session: https://claude.ai/code/session_011iFrL2Hfizgp6kYckDtNGc
</commit_message>
<xml_diff>
--- a/思考页.pptx
+++ b/思考页.pptx
@@ -5843,7 +5843,7 @@
                 <a:ea typeface="微软雅黑"/>
                 <a:cs typeface="微软雅黑"/>
               </a:rPr>
-              <a:t>小红书</a:t>
+              <a:t>对模型能力负责</a:t>
             </a:r>
           </a:p>
         </p:txBody>
@@ -6200,7 +6200,7 @@
                 <a:ea typeface="微软雅黑"/>
                 <a:cs typeface="微软雅黑"/>
               </a:rPr>
-              <a:t>携程 · 火车票</a:t>
+              <a:t>对业务结果负责</a:t>
             </a:r>
           </a:p>
         </p:txBody>

</xml_diff>

<commit_message>
Enlarge text on reflection slide
Co-Authored-By: Claude Opus 5.5 <noreply@anthropic.com>
Claude-Session: https://claude.ai/code/session_011iFrL2Hfizgp6kYckDtNGc
</commit_message>
<xml_diff>
--- a/思考页.pptx
+++ b/思考页.pptx
@@ -5689,8 +5689,8 @@
         </p:nvSpPr>
         <p:spPr>
           <a:xfrm>
-            <a:off x="457200" y="1554480"/>
-            <a:ext cx="3383280" cy="3474720"/>
+            <a:off x="457200" y="1508760"/>
+            <a:ext cx="3429000" cy="3749039"/>
           </a:xfrm>
           <a:prstGeom prst="roundRect">
             <a:avLst>
@@ -5736,7 +5736,7 @@
         <p:spPr>
           <a:xfrm>
             <a:off x="731520" y="1783080"/>
-            <a:ext cx="640080" cy="640080"/>
+            <a:ext cx="777240" cy="777240"/>
           </a:xfrm>
           <a:prstGeom prst="ellipse">
             <a:avLst/>
@@ -5785,8 +5785,8 @@
         </p:blipFill>
         <p:spPr>
           <a:xfrm>
-            <a:off x="891540" y="1943100"/>
-            <a:ext cx="320040" cy="320040"/>
+            <a:off x="925830" y="1977390"/>
+            <a:ext cx="388620" cy="388620"/>
           </a:xfrm>
           <a:prstGeom prst="rect">
             <a:avLst/>
@@ -5801,8 +5801,8 @@
         </p:nvSpPr>
         <p:spPr>
           <a:xfrm>
-            <a:off x="1508760" y="1783080"/>
-            <a:ext cx="2194560" cy="640080"/>
+            <a:off x="1645920" y="1783080"/>
+            <a:ext cx="2194560" cy="777240"/>
           </a:xfrm>
           <a:prstGeom prst="rect">
             <a:avLst/>
@@ -5817,7 +5817,7 @@
           <a:p>
             <a:pPr algn="l"/>
             <a:r>
-              <a:rPr sz="1800" b="1">
+              <a:rPr sz="2200" b="1">
                 <a:solidFill>
                   <a:srgbClr val="3D4757"/>
                 </a:solidFill>
@@ -5835,7 +5835,7 @@
               </a:spcBef>
             </a:pPr>
             <a:r>
-              <a:rPr sz="1200" b="0">
+              <a:rPr sz="1400" b="0">
                 <a:solidFill>
                   <a:srgbClr val="7A8599"/>
                 </a:solidFill>
@@ -5856,8 +5856,8 @@
         </p:nvSpPr>
         <p:spPr>
           <a:xfrm>
-            <a:off x="731520" y="2743200"/>
-            <a:ext cx="2834640" cy="274320"/>
+            <a:off x="731520" y="2926080"/>
+            <a:ext cx="2926080" cy="320040"/>
           </a:xfrm>
           <a:prstGeom prst="rect">
             <a:avLst/>
@@ -5872,7 +5872,7 @@
           <a:p>
             <a:pPr algn="l"/>
             <a:r>
-              <a:rPr sz="1200" b="1">
+              <a:rPr sz="1400" b="1">
                 <a:solidFill>
                   <a:srgbClr val="7A8599"/>
                 </a:solidFill>
@@ -5893,8 +5893,8 @@
         </p:nvSpPr>
         <p:spPr>
           <a:xfrm>
-            <a:off x="731520" y="3035808"/>
-            <a:ext cx="2834640" cy="457200"/>
+            <a:off x="731520" y="3273552"/>
+            <a:ext cx="3017520" cy="548640"/>
           </a:xfrm>
           <a:prstGeom prst="rect">
             <a:avLst/>
@@ -5909,7 +5909,7 @@
           <a:p>
             <a:pPr algn="l"/>
             <a:r>
-              <a:rPr sz="1700" b="1">
+              <a:rPr sz="2200" b="1">
                 <a:solidFill>
                   <a:srgbClr val="3D4757"/>
                 </a:solidFill>
@@ -5930,8 +5930,8 @@
         </p:nvSpPr>
         <p:spPr>
           <a:xfrm>
-            <a:off x="731520" y="3794760"/>
-            <a:ext cx="2834640" cy="274320"/>
+            <a:off x="731520" y="4069080"/>
+            <a:ext cx="2926080" cy="320040"/>
           </a:xfrm>
           <a:prstGeom prst="rect">
             <a:avLst/>
@@ -5946,7 +5946,7 @@
           <a:p>
             <a:pPr algn="l"/>
             <a:r>
-              <a:rPr sz="1200" b="1">
+              <a:rPr sz="1400" b="1">
                 <a:solidFill>
                   <a:srgbClr val="7A8599"/>
                 </a:solidFill>
@@ -5967,8 +5967,8 @@
         </p:nvSpPr>
         <p:spPr>
           <a:xfrm>
-            <a:off x="731520" y="4087368"/>
-            <a:ext cx="2834640" cy="457200"/>
+            <a:off x="731520" y="4416552"/>
+            <a:ext cx="3017520" cy="548640"/>
           </a:xfrm>
           <a:prstGeom prst="rect">
             <a:avLst/>
@@ -5983,7 +5983,7 @@
           <a:p>
             <a:pPr algn="l"/>
             <a:r>
-              <a:rPr sz="1700" b="1">
+              <a:rPr sz="2200" b="1">
                 <a:solidFill>
                   <a:srgbClr val="3D4757"/>
                 </a:solidFill>
@@ -6004,8 +6004,8 @@
         </p:nvSpPr>
         <p:spPr>
           <a:xfrm>
-            <a:off x="3977639" y="3063240"/>
-            <a:ext cx="502920" cy="457200"/>
+            <a:off x="4005072" y="3108960"/>
+            <a:ext cx="548640" cy="548640"/>
           </a:xfrm>
           <a:prstGeom prst="rightArrow">
             <a:avLst/>
@@ -6046,8 +6046,8 @@
         </p:nvSpPr>
         <p:spPr>
           <a:xfrm>
-            <a:off x="4617720" y="1554480"/>
-            <a:ext cx="7114032" cy="3474720"/>
+            <a:off x="4681728" y="1508760"/>
+            <a:ext cx="7050024" cy="3749039"/>
           </a:xfrm>
           <a:prstGeom prst="roundRect">
             <a:avLst>
@@ -6092,8 +6092,8 @@
         </p:nvSpPr>
         <p:spPr>
           <a:xfrm>
-            <a:off x="4892040" y="1783080"/>
-            <a:ext cx="640080" cy="640080"/>
+            <a:off x="4956048" y="1783080"/>
+            <a:ext cx="777240" cy="777240"/>
           </a:xfrm>
           <a:prstGeom prst="ellipse">
             <a:avLst/>
@@ -6142,8 +6142,8 @@
         </p:blipFill>
         <p:spPr>
           <a:xfrm>
-            <a:off x="5052059" y="1943100"/>
-            <a:ext cx="320040" cy="320040"/>
+            <a:off x="5150358" y="1977390"/>
+            <a:ext cx="388620" cy="388620"/>
           </a:xfrm>
           <a:prstGeom prst="rect">
             <a:avLst/>
@@ -6158,8 +6158,8 @@
         </p:nvSpPr>
         <p:spPr>
           <a:xfrm>
-            <a:off x="5669280" y="1783080"/>
-            <a:ext cx="2743200" cy="640080"/>
+            <a:off x="5870448" y="1783080"/>
+            <a:ext cx="2743200" cy="777240"/>
           </a:xfrm>
           <a:prstGeom prst="rect">
             <a:avLst/>
@@ -6174,7 +6174,7 @@
           <a:p>
             <a:pPr algn="l"/>
             <a:r>
-              <a:rPr sz="1800" b="1">
+              <a:rPr sz="2200" b="1">
                 <a:solidFill>
                   <a:srgbClr val="287DFA"/>
                 </a:solidFill>
@@ -6192,7 +6192,7 @@
               </a:spcBef>
             </a:pPr>
             <a:r>
-              <a:rPr sz="1200" b="0">
+              <a:rPr sz="1400" b="0">
                 <a:solidFill>
                   <a:srgbClr val="7A8599"/>
                 </a:solidFill>
@@ -6213,8 +6213,8 @@
         </p:nvSpPr>
         <p:spPr>
           <a:xfrm>
-            <a:off x="8229600" y="1783080"/>
-            <a:ext cx="3291840" cy="640080"/>
+            <a:off x="8247888" y="1783080"/>
+            <a:ext cx="3246120" cy="777240"/>
           </a:xfrm>
           <a:prstGeom prst="rect">
             <a:avLst/>
@@ -6229,7 +6229,7 @@
           <a:p>
             <a:pPr algn="r"/>
             <a:r>
-              <a:rPr sz="1500" b="1">
+              <a:rPr sz="1800" b="1">
                 <a:solidFill>
                   <a:srgbClr val="15315E"/>
                 </a:solidFill>
@@ -6250,8 +6250,8 @@
         </p:nvSpPr>
         <p:spPr>
           <a:xfrm>
-            <a:off x="4892040" y="2697480"/>
-            <a:ext cx="6583680" cy="621792"/>
+            <a:off x="4956048" y="2788920"/>
+            <a:ext cx="6501384" cy="694944"/>
           </a:xfrm>
           <a:prstGeom prst="roundRect">
             <a:avLst>
@@ -6294,8 +6294,8 @@
         </p:nvSpPr>
         <p:spPr>
           <a:xfrm>
-            <a:off x="5029200" y="2798064"/>
-            <a:ext cx="420624" cy="420624"/>
+            <a:off x="5093208" y="2898648"/>
+            <a:ext cx="475488" cy="475488"/>
           </a:xfrm>
           <a:prstGeom prst="ellipse">
             <a:avLst/>
@@ -6344,8 +6344,8 @@
         </p:blipFill>
         <p:spPr>
           <a:xfrm>
-            <a:off x="5134356" y="2903220"/>
-            <a:ext cx="210312" cy="210312"/>
+            <a:off x="5212080" y="3017520"/>
+            <a:ext cx="237744" cy="237744"/>
           </a:xfrm>
           <a:prstGeom prst="rect">
             <a:avLst/>
@@ -6360,8 +6360,8 @@
         </p:nvSpPr>
         <p:spPr>
           <a:xfrm>
-            <a:off x="5577840" y="2697480"/>
-            <a:ext cx="731520" cy="621792"/>
+            <a:off x="5705856" y="2788920"/>
+            <a:ext cx="777240" cy="694944"/>
           </a:xfrm>
           <a:prstGeom prst="rect">
             <a:avLst/>
@@ -6376,7 +6376,7 @@
           <a:p>
             <a:pPr algn="l"/>
             <a:r>
-              <a:rPr sz="1500" b="1">
+              <a:rPr sz="1800" b="1">
                 <a:solidFill>
                   <a:srgbClr val="287DFA"/>
                 </a:solidFill>
@@ -6397,8 +6397,8 @@
         </p:nvSpPr>
         <p:spPr>
           <a:xfrm>
-            <a:off x="6309360" y="2697480"/>
-            <a:ext cx="5074920" cy="621792"/>
+            <a:off x="6510528" y="2788920"/>
+            <a:ext cx="4983480" cy="694944"/>
           </a:xfrm>
           <a:prstGeom prst="rect">
             <a:avLst/>
@@ -6413,7 +6413,7 @@
           <a:p>
             <a:pPr algn="l"/>
             <a:r>
-              <a:rPr sz="1400" b="0">
+              <a:rPr sz="1600" b="0">
                 <a:solidFill>
                   <a:srgbClr val="3D4757"/>
                 </a:solidFill>
@@ -6434,8 +6434,8 @@
         </p:nvSpPr>
         <p:spPr>
           <a:xfrm>
-            <a:off x="4892040" y="3447288"/>
-            <a:ext cx="6583680" cy="621792"/>
+            <a:off x="4956048" y="3593591"/>
+            <a:ext cx="6501384" cy="694944"/>
           </a:xfrm>
           <a:prstGeom prst="roundRect">
             <a:avLst>
@@ -6478,8 +6478,8 @@
         </p:nvSpPr>
         <p:spPr>
           <a:xfrm>
-            <a:off x="5029200" y="3547872"/>
-            <a:ext cx="420624" cy="420624"/>
+            <a:off x="5093208" y="3703320"/>
+            <a:ext cx="475488" cy="475488"/>
           </a:xfrm>
           <a:prstGeom prst="ellipse">
             <a:avLst/>
@@ -6528,8 +6528,8 @@
         </p:blipFill>
         <p:spPr>
           <a:xfrm>
-            <a:off x="5134356" y="3653028"/>
-            <a:ext cx="210312" cy="210312"/>
+            <a:off x="5212080" y="3822191"/>
+            <a:ext cx="237744" cy="237744"/>
           </a:xfrm>
           <a:prstGeom prst="rect">
             <a:avLst/>
@@ -6544,8 +6544,8 @@
         </p:nvSpPr>
         <p:spPr>
           <a:xfrm>
-            <a:off x="5577840" y="3447288"/>
-            <a:ext cx="731520" cy="621792"/>
+            <a:off x="5705856" y="3593591"/>
+            <a:ext cx="777240" cy="694944"/>
           </a:xfrm>
           <a:prstGeom prst="rect">
             <a:avLst/>
@@ -6560,7 +6560,7 @@
           <a:p>
             <a:pPr algn="l"/>
             <a:r>
-              <a:rPr sz="1500" b="1">
+              <a:rPr sz="1800" b="1">
                 <a:solidFill>
                   <a:srgbClr val="287DFA"/>
                 </a:solidFill>
@@ -6581,8 +6581,8 @@
         </p:nvSpPr>
         <p:spPr>
           <a:xfrm>
-            <a:off x="6309360" y="3447288"/>
-            <a:ext cx="5074920" cy="621792"/>
+            <a:off x="6510528" y="3593591"/>
+            <a:ext cx="4983480" cy="694944"/>
           </a:xfrm>
           <a:prstGeom prst="rect">
             <a:avLst/>
@@ -6597,7 +6597,7 @@
           <a:p>
             <a:pPr algn="l"/>
             <a:r>
-              <a:rPr sz="1400" b="0">
+              <a:rPr sz="1600" b="0">
                 <a:solidFill>
                   <a:srgbClr val="3D4757"/>
                 </a:solidFill>
@@ -6605,7 +6605,7 @@
                 <a:ea typeface="微软雅黑"/>
                 <a:cs typeface="微软雅黑"/>
               </a:rPr>
-              <a:t>贴合用户习惯：对话 → 直接操作列表页，票量明显提升</a:t>
+              <a:t>贴合用户习惯：对话 → 列表页，票量明显提升</a:t>
             </a:r>
           </a:p>
         </p:txBody>
@@ -6618,8 +6618,8 @@
         </p:nvSpPr>
         <p:spPr>
           <a:xfrm>
-            <a:off x="4892040" y="4197096"/>
-            <a:ext cx="6583680" cy="621792"/>
+            <a:off x="4956048" y="4398264"/>
+            <a:ext cx="6501384" cy="694944"/>
           </a:xfrm>
           <a:prstGeom prst="roundRect">
             <a:avLst>
@@ -6662,8 +6662,8 @@
         </p:nvSpPr>
         <p:spPr>
           <a:xfrm>
-            <a:off x="5029200" y="4297680"/>
-            <a:ext cx="420624" cy="420624"/>
+            <a:off x="5093208" y="4507992"/>
+            <a:ext cx="475488" cy="475488"/>
           </a:xfrm>
           <a:prstGeom prst="ellipse">
             <a:avLst/>
@@ -6712,8 +6712,8 @@
         </p:blipFill>
         <p:spPr>
           <a:xfrm>
-            <a:off x="5134356" y="4402836"/>
-            <a:ext cx="210312" cy="210312"/>
+            <a:off x="5212080" y="4626864"/>
+            <a:ext cx="237744" cy="237744"/>
           </a:xfrm>
           <a:prstGeom prst="rect">
             <a:avLst/>
@@ -6728,8 +6728,8 @@
         </p:nvSpPr>
         <p:spPr>
           <a:xfrm>
-            <a:off x="5577840" y="4197096"/>
-            <a:ext cx="731520" cy="621792"/>
+            <a:off x="5705856" y="4398264"/>
+            <a:ext cx="777240" cy="694944"/>
           </a:xfrm>
           <a:prstGeom prst="rect">
             <a:avLst/>
@@ -6744,7 +6744,7 @@
           <a:p>
             <a:pPr algn="l"/>
             <a:r>
-              <a:rPr sz="1500" b="1">
+              <a:rPr sz="1800" b="1">
                 <a:solidFill>
                   <a:srgbClr val="287DFA"/>
                 </a:solidFill>
@@ -6765,8 +6765,8 @@
         </p:nvSpPr>
         <p:spPr>
           <a:xfrm>
-            <a:off x="6309360" y="4197096"/>
-            <a:ext cx="5074920" cy="621792"/>
+            <a:off x="6510528" y="4398264"/>
+            <a:ext cx="4983480" cy="694944"/>
           </a:xfrm>
           <a:prstGeom prst="rect">
             <a:avLst/>
@@ -6781,7 +6781,7 @@
           <a:p>
             <a:pPr algn="l"/>
             <a:r>
-              <a:rPr sz="1400" b="0">
+              <a:rPr sz="1600" b="0">
                 <a:solidFill>
                   <a:srgbClr val="3D4757"/>
                 </a:solidFill>
@@ -6802,8 +6802,8 @@
         </p:nvSpPr>
         <p:spPr>
           <a:xfrm>
-            <a:off x="457200" y="5257800"/>
-            <a:ext cx="11274552" cy="822960"/>
+            <a:off x="457200" y="5440680"/>
+            <a:ext cx="11274552" cy="777240"/>
           </a:xfrm>
           <a:prstGeom prst="roundRect">
             <a:avLst>
@@ -6854,8 +6854,8 @@
         </p:blipFill>
         <p:spPr>
           <a:xfrm>
-            <a:off x="777240" y="5458968"/>
-            <a:ext cx="420624" cy="420624"/>
+            <a:off x="777240" y="5614416"/>
+            <a:ext cx="438912" cy="438912"/>
           </a:xfrm>
           <a:prstGeom prst="rect">
             <a:avLst/>
@@ -6870,8 +6870,8 @@
         </p:nvSpPr>
         <p:spPr>
           <a:xfrm>
-            <a:off x="1417320" y="5257800"/>
-            <a:ext cx="10149840" cy="822960"/>
+            <a:off x="1417320" y="5440680"/>
+            <a:ext cx="10149840" cy="777240"/>
           </a:xfrm>
           <a:prstGeom prst="rect">
             <a:avLst/>
@@ -6886,7 +6886,7 @@
           <a:p>
             <a:pPr algn="l"/>
             <a:r>
-              <a:rPr sz="1800" b="1">
+              <a:rPr sz="2000" b="1">
                 <a:solidFill>
                   <a:srgbClr val="D6E6FF"/>
                 </a:solidFill>
@@ -6897,7 +6897,7 @@
               <a:t>探索 AI + 业务时，先想清楚：</a:t>
             </a:r>
             <a:r>
-              <a:rPr sz="1800" b="1">
+              <a:rPr sz="2000" b="1">
                 <a:solidFill>
                   <a:srgbClr val="FFFFFF"/>
                 </a:solidFill>

</xml_diff>